<commit_message>
Fix layout issues in M10 and M11 slides (footer overlaps, code block overflow)
</commit_message>
<xml_diff>
--- a/contents/Module-10-Basic-Troubleshooting.pptx
+++ b/contents/Module-10-Basic-Troubleshooting.pptx
@@ -6327,7 +6327,7 @@
         <p:spPr>
           <a:xfrm>
             <a:off x="411480" y="6080760"/>
-            <a:ext cx="7315200" cy="475488"/>
+            <a:ext cx="7315200" cy="365760"/>
           </a:xfrm>
           <a:prstGeom prst="rect">
             <a:avLst/>
@@ -6370,7 +6370,7 @@
         <p:spPr>
           <a:xfrm>
             <a:off x="576072" y="6190488"/>
-            <a:ext cx="6986016" cy="256032"/>
+            <a:ext cx="6986016" cy="146304"/>
           </a:xfrm>
           <a:prstGeom prst="rect">
             <a:avLst/>
@@ -8321,7 +8321,7 @@
         <p:spPr>
           <a:xfrm>
             <a:off x="457200" y="2395728"/>
-            <a:ext cx="347472" cy="1170432"/>
+            <a:ext cx="347472" cy="1078992"/>
           </a:xfrm>
           <a:prstGeom prst="rect">
             <a:avLst/>
@@ -8398,8 +8398,8 @@
         </p:nvSpPr>
         <p:spPr>
           <a:xfrm>
-            <a:off x="960120" y="2834640"/>
-            <a:ext cx="10744200" cy="594360"/>
+            <a:off x="960120" y="2816352"/>
+            <a:ext cx="10744200" cy="548640"/>
           </a:xfrm>
           <a:prstGeom prst="rect">
             <a:avLst/>
@@ -8435,8 +8435,8 @@
         </p:nvSpPr>
         <p:spPr>
           <a:xfrm>
-            <a:off x="457200" y="3785616"/>
-            <a:ext cx="347472" cy="1170432"/>
+            <a:off x="457200" y="3657600"/>
+            <a:ext cx="347472" cy="1078992"/>
           </a:xfrm>
           <a:prstGeom prst="rect">
             <a:avLst/>
@@ -8478,7 +8478,7 @@
         </p:nvSpPr>
         <p:spPr>
           <a:xfrm>
-            <a:off x="960120" y="3858768"/>
+            <a:off x="960120" y="3730752"/>
             <a:ext cx="10744200" cy="292608"/>
           </a:xfrm>
           <a:prstGeom prst="rect">
@@ -8513,8 +8513,8 @@
         </p:nvSpPr>
         <p:spPr>
           <a:xfrm>
-            <a:off x="960120" y="4224528"/>
-            <a:ext cx="10744200" cy="594360"/>
+            <a:off x="960120" y="4078224"/>
+            <a:ext cx="10744200" cy="548640"/>
           </a:xfrm>
           <a:prstGeom prst="rect">
             <a:avLst/>
@@ -8550,8 +8550,8 @@
         </p:nvSpPr>
         <p:spPr>
           <a:xfrm>
-            <a:off x="457200" y="5175504"/>
-            <a:ext cx="347472" cy="1170432"/>
+            <a:off x="457200" y="4919472"/>
+            <a:ext cx="347472" cy="1078992"/>
           </a:xfrm>
           <a:prstGeom prst="rect">
             <a:avLst/>
@@ -8593,7 +8593,7 @@
         </p:nvSpPr>
         <p:spPr>
           <a:xfrm>
-            <a:off x="960120" y="5248656"/>
+            <a:off x="960120" y="4992624"/>
             <a:ext cx="10744200" cy="292608"/>
           </a:xfrm>
           <a:prstGeom prst="rect">
@@ -8628,8 +8628,8 @@
         </p:nvSpPr>
         <p:spPr>
           <a:xfrm>
-            <a:off x="960120" y="5614416"/>
-            <a:ext cx="10744200" cy="594360"/>
+            <a:off x="960120" y="5340096"/>
+            <a:ext cx="10744200" cy="548640"/>
           </a:xfrm>
           <a:prstGeom prst="rect">
             <a:avLst/>
@@ -8665,8 +8665,8 @@
         </p:nvSpPr>
         <p:spPr>
           <a:xfrm>
-            <a:off x="457200" y="6446520"/>
-            <a:ext cx="11247120" cy="274320"/>
+            <a:off x="457200" y="6144768"/>
+            <a:ext cx="11247120" cy="256032"/>
           </a:xfrm>
           <a:prstGeom prst="rect">
             <a:avLst/>

</xml_diff>